<commit_message>
fix(stky): correct shop-param framing — creations-gdc is HairMNL's primary myshopify subdomain
User clarified that creations-gdc.myshopify.com IS hairmnl.com's correct
primary myshopify subdomain — not a stale leftover from a forked theme.

The hardcoded <script> tag at layout/theme.liquid:969 is still worth
deleting, but the reason is different: it duplicates the Shopify App
Embed (both paths load the same Stky script with the same correct
shop param). Net effect = one wasted script load per page.

Updates:
- ARCHITECTURE.md § Stky — reworded drivers + file table
- docs/feasibility-replace-stky.pptx — slide 3 issue 1, slide 4 callout,
  slide 9 appendix file inventory
- bd hairmnl-theme-a7av epic + a7av.1 + a7av.7 — correction notes appended

Co-Authored-By: Claude Opus 4.7 <noreply@anthropic.com>
</commit_message>
<xml_diff>
--- a/docs/feasibility-replace-stky.pptx
+++ b/docs/feasibility-replace-stky.pptx
@@ -2743,7 +2743,7 @@
                 <a:ea typeface="Calibri" pitchFamily="34" charset="-122"/>
                 <a:cs typeface="Calibri" pitchFamily="34" charset="-120"/>
               </a:rPr>
-              <a:t>Issue 1 — Hardcoded script with the wrong shop parameter</a:t>
+              <a:t>Issue 1 — Hardcoded script tag duplicates the Shopify App Embed</a:t>
             </a:r>
             <a:endParaRPr lang="en-US" sz="1300" dirty="0"/>
           </a:p>
@@ -2782,7 +2782,7 @@
                 <a:ea typeface="Calibri" pitchFamily="34" charset="-122"/>
                 <a:cs typeface="Calibri" pitchFamily="34" charset="-120"/>
               </a:rPr>
-              <a:t>layout/theme.liquid:969 contains a hardcoded </a:t>
+              <a:t>layout/theme.liquid:969 hardcodes a </a:t>
             </a:r>
             <a:pPr indent="0" marL="0">
               <a:buNone/>
@@ -2796,7 +2796,7 @@
                 <a:ea typeface="Consolas" pitchFamily="34" charset="-122"/>
                 <a:cs typeface="Consolas" pitchFamily="34" charset="-120"/>
               </a:rPr>
-              <a:t>&lt;script src="…/satcb.min.js?shop=creations-gdc.myshopify.com"&gt;</a:t>
+              <a:t>&lt;script src="…/satcb.min.js?shop=…"&gt;</a:t>
             </a:r>
             <a:pPr indent="0" marL="0">
               <a:buNone/>
@@ -2810,7 +2810,7 @@
                 <a:ea typeface="Calibri" pitchFamily="34" charset="-122"/>
                 <a:cs typeface="Calibri" pitchFamily="34" charset="-120"/>
               </a:rPr>
-              <a:t> — a leftover from when this theme was forked from another store. It loads on every page in parallel with the legitimate Shopify App Embed, doubling the third-party script cost and potentially mis-attributing analytics. </a:t>
+              <a:t> tag with the correct shop identifier, but Stky is ALSO loaded via Shopify's App Embed (config/settings_data.json). The result is the same third-party script loading twice on every page — wasted bandwidth, duplicate event listeners, potentially conflicting state. </a:t>
             </a:r>
             <a:pPr indent="0" marL="0">
               <a:buNone/>
@@ -2824,7 +2824,7 @@
                 <a:ea typeface="Calibri" pitchFamily="34" charset="-122"/>
                 <a:cs typeface="Calibri" pitchFamily="34" charset="-120"/>
               </a:rPr>
-              <a:t>Should be removed regardless of whether Stky stays.</a:t>
+              <a:t>The hardcoded tag is the legacy path (pre-App-Embed) and should be removed regardless of whether Stky stays.</a:t>
             </a:r>
             <a:endParaRPr lang="en-US" sz="1150" dirty="0"/>
           </a:p>
@@ -4080,7 +4080,7 @@
                 <a:ea typeface="Calibri" pitchFamily="34" charset="-122"/>
                 <a:cs typeface="Calibri" pitchFamily="34" charset="-120"/>
               </a:rPr>
-              <a:t>Eliminates ~600ms Azure latency, the duplicate script tag, and the stale shop parameter.</a:t>
+              <a:t>Eliminates ~600ms Azure latency and the duplicate Stky script load (App Embed + hardcoded tag).</a:t>
             </a:r>
             <a:endParaRPr lang="en-US" sz="1100" dirty="0"/>
           </a:p>
@@ -9126,7 +9126,7 @@
                 <a:ea typeface="Calibri" pitchFamily="34" charset="-122"/>
                 <a:cs typeface="Calibri" pitchFamily="34" charset="-120"/>
               </a:rPr>
-              <a:t>layout/theme.liquid:969 (hardcoded script with wrong shop param)</a:t>
+              <a:t>layout/theme.liquid:969 (legacy hardcoded script — duplicates the Shopify App Embed)</a:t>
             </a:r>
             <a:endParaRPr lang="en-US" sz="1100" dirty="0"/>
           </a:p>

</xml_diff>